<commit_message>
Add team credits to pitch deck cover and closing
Team: Puneet Pahuja (Team Lead), Khushboo Verma, Anurag Verma.

Co-authored-by: Copilot <223556219+Copilot@users.noreply.github.com>
</commit_message>
<xml_diff>
--- a/submission/Kairos-AI-Pitch-Deck.pptx
+++ b/submission/Kairos-AI-Pitch-Deck.pptx
@@ -3586,7 +3586,68 @@
         </p:nvSpPr>
         <p:spPr>
           <a:xfrm>
-            <a:off x="868680" y="5806440"/>
+            <a:off x="868680" y="5577840"/>
+            <a:ext cx="10515600" cy="320040"/>
+          </a:xfrm>
+          <a:prstGeom prst="rect">
+            <a:avLst/>
+          </a:prstGeom>
+          <a:noFill/>
+        </p:spPr>
+        <p:txBody>
+          <a:bodyPr wrap="square" anchor="t" lIns="0" rIns="0" tIns="0" bIns="0">
+            <a:spAutoFit/>
+          </a:bodyPr>
+          <a:lstStyle/>
+          <a:p>
+            <a:pPr algn="l">
+              <a:spcBef>
+                <a:spcPts val="0"/>
+              </a:spcBef>
+              <a:spcAft>
+                <a:spcPts val="0"/>
+              </a:spcAft>
+            </a:pPr>
+            <a:r>
+              <a:rPr sz="1200" b="1">
+                <a:solidFill>
+                  <a:srgbClr val="2DD4BF"/>
+                </a:solidFill>
+                <a:latin typeface="Calibri"/>
+              </a:rPr>
+              <a:t>Team:  </a:t>
+            </a:r>
+          </a:p>
+          <a:p>
+            <a:pPr algn="l">
+              <a:spcBef>
+                <a:spcPts val="0"/>
+              </a:spcBef>
+              <a:spcAft>
+                <a:spcPts val="400"/>
+              </a:spcAft>
+            </a:pPr>
+            <a:r>
+              <a:rPr sz="1200" b="0">
+                <a:solidFill>
+                  <a:srgbClr val="F4F7FB"/>
+                </a:solidFill>
+                <a:latin typeface="Calibri"/>
+              </a:rPr>
+              <a:t>Puneet Pahuja (Team Lead)  ·  Khushboo Verma  ·  Anurag Verma</a:t>
+            </a:r>
+          </a:p>
+        </p:txBody>
+      </p:sp>
+      <p:sp>
+        <p:nvSpPr>
+          <p:cNvPr id="13" name="TextBox 12"/>
+          <p:cNvSpPr txBox="1"/>
+          <p:nvPr/>
+        </p:nvSpPr>
+        <p:spPr>
+          <a:xfrm>
+            <a:off x="868680" y="5943600"/>
             <a:ext cx="10515600" cy="457200"/>
           </a:xfrm>
           <a:prstGeom prst="rect">
@@ -9773,7 +9834,7 @@
         </p:nvSpPr>
         <p:spPr>
           <a:xfrm>
-            <a:off x="822960" y="4160520"/>
+            <a:off x="822960" y="4114800"/>
             <a:ext cx="10424160" cy="1188720"/>
           </a:xfrm>
           <a:prstGeom prst="rect">
@@ -9834,8 +9895,8 @@
         </p:nvSpPr>
         <p:spPr>
           <a:xfrm>
-            <a:off x="868680" y="5623560"/>
-            <a:ext cx="10332720" cy="457200"/>
+            <a:off x="868680" y="5532120"/>
+            <a:ext cx="10332720" cy="320040"/>
           </a:xfrm>
           <a:prstGeom prst="rect">
             <a:avLst/>
@@ -9847,6 +9908,25 @@
             <a:spAutoFit/>
           </a:bodyPr>
           <a:lstStyle/>
+          <a:p>
+            <a:pPr algn="l">
+              <a:spcBef>
+                <a:spcPts val="0"/>
+              </a:spcBef>
+              <a:spcAft>
+                <a:spcPts val="0"/>
+              </a:spcAft>
+            </a:pPr>
+            <a:r>
+              <a:rPr sz="1150" b="1">
+                <a:solidFill>
+                  <a:srgbClr val="2DD4BF"/>
+                </a:solidFill>
+                <a:latin typeface="Calibri"/>
+              </a:rPr>
+              <a:t>Team:  </a:t>
+            </a:r>
+          </a:p>
           <a:p>
             <a:pPr algn="l">
               <a:spcBef>
@@ -9859,11 +9939,11 @@
             <a:r>
               <a:rPr sz="1150" b="0">
                 <a:solidFill>
-                  <a:srgbClr val="9FB3C8"/>
+                  <a:srgbClr val="F4F7FB"/>
                 </a:solidFill>
                 <a:latin typeface="Calibri"/>
               </a:rPr>
-              <a:t>Live · kairos-ai-498775210896.asia-south1.run.app      ·      github.com/puneetpahuja-eaton/kairos-ai</a:t>
+              <a:t>Puneet Pahuja (Team Lead)  ·  Khushboo Verma  ·  Anurag Verma</a:t>
             </a:r>
           </a:p>
         </p:txBody>
@@ -9876,7 +9956,7 @@
         </p:nvSpPr>
         <p:spPr>
           <a:xfrm>
-            <a:off x="868680" y="6035040"/>
+            <a:off x="868680" y="5870448"/>
             <a:ext cx="10332720" cy="365760"/>
           </a:xfrm>
           <a:prstGeom prst="rect">
@@ -9899,13 +9979,55 @@
               </a:spcAft>
             </a:pPr>
             <a:r>
-              <a:rPr sz="1050" b="1">
-                <a:solidFill>
-                  <a:srgbClr val="2DD4BF"/>
+              <a:rPr sz="1050" b="0">
+                <a:solidFill>
+                  <a:srgbClr val="9FB3C8"/>
                 </a:solidFill>
                 <a:latin typeface="Calibri"/>
               </a:rPr>
-              <a:t>121 automated tests · deployed &amp; verified on Cloud Run · Firestore-backed · Gemini on Vertex AI</a:t>
+              <a:t>Live · kairos-ai-498775210896.asia-south1.run.app   ·   github.com/puneetpahuja-eaton/kairos-ai</a:t>
+            </a:r>
+          </a:p>
+        </p:txBody>
+      </p:sp>
+      <p:sp>
+        <p:nvSpPr>
+          <p:cNvPr id="12" name="TextBox 11"/>
+          <p:cNvSpPr txBox="1"/>
+          <p:nvPr/>
+        </p:nvSpPr>
+        <p:spPr>
+          <a:xfrm>
+            <a:off x="868680" y="6199632"/>
+            <a:ext cx="10332720" cy="320040"/>
+          </a:xfrm>
+          <a:prstGeom prst="rect">
+            <a:avLst/>
+          </a:prstGeom>
+          <a:noFill/>
+        </p:spPr>
+        <p:txBody>
+          <a:bodyPr wrap="square" anchor="t" lIns="0" rIns="0" tIns="0" bIns="0">
+            <a:spAutoFit/>
+          </a:bodyPr>
+          <a:lstStyle/>
+          <a:p>
+            <a:pPr algn="l">
+              <a:spcBef>
+                <a:spcPts val="0"/>
+              </a:spcBef>
+              <a:spcAft>
+                <a:spcPts val="400"/>
+              </a:spcAft>
+            </a:pPr>
+            <a:r>
+              <a:rPr sz="1000" b="1">
+                <a:solidFill>
+                  <a:srgbClr val="2DD4BF"/>
+                </a:solidFill>
+                <a:latin typeface="Calibri"/>
+              </a:rPr>
+              <a:t>121 automated tests · deployed &amp; verified on Cloud Run · Gemini on Vertex AI</a:t>
             </a:r>
           </a:p>
         </p:txBody>

</xml_diff>